<commit_message>
docs: update project report and presentation with verified ER, Oracle, MongoDB Atlas, and UI screenshots
</commit_message>
<xml_diff>
--- a/docs/FORENSYS_DA3_Presentation.pptx
+++ b/docs/FORENSYS_DA3_Presentation.pptx
@@ -8435,7 +8435,7 @@
       </p:sp>
       <p:pic>
         <p:nvPicPr>
-          <p:cNvPr id="4" name="Picture 3" descr="media_1789148621879.png"/>
+          <p:cNvPr id="4" name="Picture 3" descr="oracle_tables_verification.png"/>
           <p:cNvPicPr>
             <a:picLocks noChangeAspect="1"/>
           </p:cNvPicPr>
@@ -8488,14 +8488,14 @@
               </a:defRPr>
             </a:pPr>
             <a:r>
-              <a:t>Figure 1: Oracle 11g SQL*Plus Execution — Schema DDL &amp; Integrity Triggers</a:t>
+              <a:t>Figure 1: Oracle 11g SQL*Plus Execution — Schema Table Catalog &amp; Row Verification</a:t>
             </a:r>
           </a:p>
         </p:txBody>
       </p:sp>
       <p:pic>
         <p:nvPicPr>
-          <p:cNvPr id="6" name="Picture 5" descr="media_1792400285638_c39904d6.jpg"/>
+          <p:cNvPr id="6" name="Picture 5" descr="ui_intelligence_graph.png"/>
           <p:cNvPicPr>
             <a:picLocks noChangeAspect="1"/>
           </p:cNvPicPr>
@@ -8548,7 +8548,7 @@
               </a:defRPr>
             </a:pPr>
             <a:r>
-              <a:t>Figure 2: Live FORENSYS Web Client — Analytics Dashboard &amp; Case Management</a:t>
+              <a:t>Figure 2: Live FORENSYS Web Client — Cross-Case Linkage &amp; Intelligence Graph</a:t>
             </a:r>
           </a:p>
         </p:txBody>

</xml_diff>